<commit_message>
Integrate official video-call/social assets into brand kit
- Add teal accent (#24D8CC) + mint, energy gradient, and a full dark theme
  to design-tokens.json and unlimit-brand.css ([data-theme=dark]/.unl-dark)
- Document logo+descriptor lockup and 'Borderless [X]' tagline system,
  dark-mode usage and new asset categories in BRAND_GUIDE.md
- Add official video-call backgrounds (light/dark, 1920x1080) and LinkedIn
  cover (1584x396) under backgrounds/ and social/
- Add LinkedIn banner template (1584x396), transparent wordmark, and a
  dark-theme page in the brand book PDF + a dark slide in the PPTX
- Refresh README as a kit index

Co-Authored-By: Claude Opus 4.8 (1M context) <noreply@anthropic.com>
Claude-Session: https://claude.ai/code/session_01KkPiFTEgVHHQBkZEALmwVX
</commit_message>
<xml_diff>
--- a/brand_extract/assets/Unlimit_Brand_Template.pptx
+++ b/brand_extract/assets/Unlimit_Brand_Template.pptx
@@ -9,6 +9,7 @@
     <p:sldId id="257" r:id="rId8"/>
     <p:sldId id="258" r:id="rId9"/>
     <p:sldId id="259" r:id="rId10"/>
+    <p:sldId id="260" r:id="rId11"/>
   </p:sldIdLst>
   <p:sldSz cx="12191695" cy="6858000" type="screen4x3"/>
   <p:notesSz cx="6858000" cy="9144000"/>
@@ -4459,6 +4460,521 @@
                 <a:latin typeface="Inter"/>
               </a:rPr>
               <a:t>Gradient:  blue → green → purple (#756AF3 → #4F93F0 → #7BE36B → #6700FB)</a:t>
+            </a:r>
+          </a:p>
+        </p:txBody>
+      </p:sp>
+    </p:spTree>
+  </p:cSld>
+  <p:clrMapOvr>
+    <a:masterClrMapping/>
+  </p:clrMapOvr>
+</p:sld>
+</file>
+
+<file path=ppt/slides/slide5.xml><?xml version="1.0" encoding="utf-8"?>
+<p:sld xmlns:a="http://schemas.openxmlformats.org/drawingml/2006/main" xmlns:p="http://schemas.openxmlformats.org/presentationml/2006/main" xmlns:r="http://schemas.openxmlformats.org/officeDocument/2006/relationships">
+  <p:cSld>
+    <p:bg>
+      <p:bgPr>
+        <a:solidFill>
+          <a:srgbClr val="1A1A1A"/>
+        </a:solidFill>
+        <a:effectLst/>
+      </p:bgPr>
+    </p:bg>
+    <p:spTree>
+      <p:nvGrpSpPr>
+        <p:cNvPr id="1" name=""/>
+        <p:cNvGrpSpPr/>
+        <p:nvPr/>
+      </p:nvGrpSpPr>
+      <p:grpSpPr/>
+      <p:pic>
+        <p:nvPicPr>
+          <p:cNvPr id="2" name="Picture 1" descr="unlimit_wordmark_white_transparent.png"/>
+          <p:cNvPicPr>
+            <a:picLocks noChangeAspect="1"/>
+          </p:cNvPicPr>
+          <p:nvPr/>
+        </p:nvPicPr>
+        <p:blipFill>
+          <a:blip r:embed="rId2"/>
+          <a:stretch>
+            <a:fillRect/>
+          </a:stretch>
+        </p:blipFill>
+        <p:spPr>
+          <a:xfrm>
+            <a:off x="640080" y="502920"/>
+            <a:ext cx="2138265" cy="502920"/>
+          </a:xfrm>
+          <a:prstGeom prst="rect">
+            <a:avLst/>
+          </a:prstGeom>
+        </p:spPr>
+      </p:pic>
+      <p:sp>
+        <p:nvSpPr>
+          <p:cNvPr id="3" name="TextBox 2"/>
+          <p:cNvSpPr txBox="1"/>
+          <p:nvPr/>
+        </p:nvSpPr>
+        <p:spPr>
+          <a:xfrm>
+            <a:off x="640080" y="1463040"/>
+            <a:ext cx="10058400" cy="914400"/>
+          </a:xfrm>
+          <a:prstGeom prst="rect">
+            <a:avLst/>
+          </a:prstGeom>
+          <a:noFill/>
+        </p:spPr>
+        <p:txBody>
+          <a:bodyPr wrap="square">
+            <a:spAutoFit/>
+          </a:bodyPr>
+          <a:lstStyle/>
+          <a:p>
+            <a:pPr algn="l"/>
+            <a:r>
+              <a:rPr sz="3600" b="1">
+                <a:solidFill>
+                  <a:srgbClr val="FFFFFF"/>
+                </a:solidFill>
+                <a:latin typeface="Nekst"/>
+              </a:rPr>
+              <a:t>Dark slide layout</a:t>
+            </a:r>
+          </a:p>
+        </p:txBody>
+      </p:sp>
+      <p:sp>
+        <p:nvSpPr>
+          <p:cNvPr id="4" name="TextBox 3"/>
+          <p:cNvSpPr txBox="1"/>
+          <p:nvPr/>
+        </p:nvSpPr>
+        <p:spPr>
+          <a:xfrm>
+            <a:off x="640080" y="2377440"/>
+            <a:ext cx="8229600" cy="731520"/>
+          </a:xfrm>
+          <a:prstGeom prst="rect">
+            <a:avLst/>
+          </a:prstGeom>
+          <a:noFill/>
+        </p:spPr>
+        <p:txBody>
+          <a:bodyPr wrap="square">
+            <a:spAutoFit/>
+          </a:bodyPr>
+          <a:lstStyle/>
+          <a:p>
+            <a:pPr algn="l"/>
+            <a:r>
+              <a:rPr sz="1800" b="0">
+                <a:solidFill>
+                  <a:srgbClr val="A8A8B0"/>
+                </a:solidFill>
+                <a:latin typeface="Inter"/>
+              </a:rPr>
+              <a:t>On dark, lime is the primary pop and teal the secondary.</a:t>
+            </a:r>
+          </a:p>
+        </p:txBody>
+      </p:sp>
+      <p:sp>
+        <p:nvSpPr>
+          <p:cNvPr id="5" name="Rounded Rectangle 4"/>
+          <p:cNvSpPr/>
+          <p:nvPr/>
+        </p:nvSpPr>
+        <p:spPr>
+          <a:xfrm>
+            <a:off x="640080" y="3383280"/>
+            <a:ext cx="1920240" cy="1188720"/>
+          </a:xfrm>
+          <a:prstGeom prst="roundRect">
+            <a:avLst/>
+          </a:prstGeom>
+          <a:solidFill>
+            <a:srgbClr val="C9F73A"/>
+          </a:solidFill>
+          <a:ln>
+            <a:noFill/>
+          </a:ln>
+          <a:effectLst/>
+        </p:spPr>
+        <p:style>
+          <a:lnRef idx="1">
+            <a:schemeClr val="accent1"/>
+          </a:lnRef>
+          <a:fillRef idx="3">
+            <a:schemeClr val="accent1"/>
+          </a:fillRef>
+          <a:effectRef idx="2">
+            <a:schemeClr val="accent1"/>
+          </a:effectRef>
+          <a:fontRef idx="minor">
+            <a:schemeClr val="lt1"/>
+          </a:fontRef>
+        </p:style>
+        <p:txBody>
+          <a:bodyPr rtlCol="0" anchor="ctr"/>
+          <a:lstStyle/>
+          <a:p>
+            <a:pPr algn="ctr"/>
+          </a:p>
+        </p:txBody>
+      </p:sp>
+      <p:sp>
+        <p:nvSpPr>
+          <p:cNvPr id="6" name="TextBox 5"/>
+          <p:cNvSpPr txBox="1"/>
+          <p:nvPr/>
+        </p:nvSpPr>
+        <p:spPr>
+          <a:xfrm>
+            <a:off x="777240" y="4480560"/>
+            <a:ext cx="1828800" cy="365760"/>
+          </a:xfrm>
+          <a:prstGeom prst="rect">
+            <a:avLst/>
+          </a:prstGeom>
+          <a:noFill/>
+        </p:spPr>
+        <p:txBody>
+          <a:bodyPr wrap="square">
+            <a:spAutoFit/>
+          </a:bodyPr>
+          <a:lstStyle/>
+          <a:p>
+            <a:pPr algn="l"/>
+            <a:r>
+              <a:rPr sz="1200" b="1">
+                <a:solidFill>
+                  <a:srgbClr val="1A1A1A"/>
+                </a:solidFill>
+                <a:latin typeface="Inter"/>
+              </a:rPr>
+              <a:t>#C9F73A</a:t>
+            </a:r>
+          </a:p>
+        </p:txBody>
+      </p:sp>
+      <p:sp>
+        <p:nvSpPr>
+          <p:cNvPr id="7" name="Rounded Rectangle 6"/>
+          <p:cNvSpPr/>
+          <p:nvPr/>
+        </p:nvSpPr>
+        <p:spPr>
+          <a:xfrm>
+            <a:off x="2834639" y="3383280"/>
+            <a:ext cx="1920240" cy="1188720"/>
+          </a:xfrm>
+          <a:prstGeom prst="roundRect">
+            <a:avLst/>
+          </a:prstGeom>
+          <a:solidFill>
+            <a:srgbClr val="24D8CC"/>
+          </a:solidFill>
+          <a:ln>
+            <a:noFill/>
+          </a:ln>
+          <a:effectLst/>
+        </p:spPr>
+        <p:style>
+          <a:lnRef idx="1">
+            <a:schemeClr val="accent1"/>
+          </a:lnRef>
+          <a:fillRef idx="3">
+            <a:schemeClr val="accent1"/>
+          </a:fillRef>
+          <a:effectRef idx="2">
+            <a:schemeClr val="accent1"/>
+          </a:effectRef>
+          <a:fontRef idx="minor">
+            <a:schemeClr val="lt1"/>
+          </a:fontRef>
+        </p:style>
+        <p:txBody>
+          <a:bodyPr rtlCol="0" anchor="ctr"/>
+          <a:lstStyle/>
+          <a:p>
+            <a:pPr algn="ctr"/>
+          </a:p>
+        </p:txBody>
+      </p:sp>
+      <p:sp>
+        <p:nvSpPr>
+          <p:cNvPr id="8" name="TextBox 7"/>
+          <p:cNvSpPr txBox="1"/>
+          <p:nvPr/>
+        </p:nvSpPr>
+        <p:spPr>
+          <a:xfrm>
+            <a:off x="2971799" y="4480560"/>
+            <a:ext cx="1828800" cy="365760"/>
+          </a:xfrm>
+          <a:prstGeom prst="rect">
+            <a:avLst/>
+          </a:prstGeom>
+          <a:noFill/>
+        </p:spPr>
+        <p:txBody>
+          <a:bodyPr wrap="square">
+            <a:spAutoFit/>
+          </a:bodyPr>
+          <a:lstStyle/>
+          <a:p>
+            <a:pPr algn="l"/>
+            <a:r>
+              <a:rPr sz="1200" b="1">
+                <a:solidFill>
+                  <a:srgbClr val="1A1A1A"/>
+                </a:solidFill>
+                <a:latin typeface="Inter"/>
+              </a:rPr>
+              <a:t>#24D8CC</a:t>
+            </a:r>
+          </a:p>
+        </p:txBody>
+      </p:sp>
+      <p:sp>
+        <p:nvSpPr>
+          <p:cNvPr id="9" name="Rounded Rectangle 8"/>
+          <p:cNvSpPr/>
+          <p:nvPr/>
+        </p:nvSpPr>
+        <p:spPr>
+          <a:xfrm>
+            <a:off x="5029200" y="3383280"/>
+            <a:ext cx="1920240" cy="1188720"/>
+          </a:xfrm>
+          <a:prstGeom prst="roundRect">
+            <a:avLst/>
+          </a:prstGeom>
+          <a:solidFill>
+            <a:srgbClr val="1A1A1A"/>
+          </a:solidFill>
+          <a:ln>
+            <a:noFill/>
+          </a:ln>
+          <a:effectLst/>
+        </p:spPr>
+        <p:style>
+          <a:lnRef idx="1">
+            <a:schemeClr val="accent1"/>
+          </a:lnRef>
+          <a:fillRef idx="3">
+            <a:schemeClr val="accent1"/>
+          </a:fillRef>
+          <a:effectRef idx="2">
+            <a:schemeClr val="accent1"/>
+          </a:effectRef>
+          <a:fontRef idx="minor">
+            <a:schemeClr val="lt1"/>
+          </a:fontRef>
+        </p:style>
+        <p:txBody>
+          <a:bodyPr rtlCol="0" anchor="ctr"/>
+          <a:lstStyle/>
+          <a:p>
+            <a:pPr algn="ctr"/>
+          </a:p>
+        </p:txBody>
+      </p:sp>
+      <p:sp>
+        <p:nvSpPr>
+          <p:cNvPr id="10" name="TextBox 9"/>
+          <p:cNvSpPr txBox="1"/>
+          <p:nvPr/>
+        </p:nvSpPr>
+        <p:spPr>
+          <a:xfrm>
+            <a:off x="5166360" y="4480560"/>
+            <a:ext cx="1828800" cy="365760"/>
+          </a:xfrm>
+          <a:prstGeom prst="rect">
+            <a:avLst/>
+          </a:prstGeom>
+          <a:noFill/>
+        </p:spPr>
+        <p:txBody>
+          <a:bodyPr wrap="square">
+            <a:spAutoFit/>
+          </a:bodyPr>
+          <a:lstStyle/>
+          <a:p>
+            <a:pPr algn="l"/>
+            <a:r>
+              <a:rPr sz="1200" b="1">
+                <a:solidFill>
+                  <a:srgbClr val="FFFFFF"/>
+                </a:solidFill>
+                <a:latin typeface="Inter"/>
+              </a:rPr>
+              <a:t>#1A1A1A</a:t>
+            </a:r>
+          </a:p>
+        </p:txBody>
+      </p:sp>
+      <p:sp>
+        <p:nvSpPr>
+          <p:cNvPr id="11" name="Rounded Rectangle 10"/>
+          <p:cNvSpPr/>
+          <p:nvPr/>
+        </p:nvSpPr>
+        <p:spPr>
+          <a:xfrm>
+            <a:off x="640080" y="5120640"/>
+            <a:ext cx="2194560" cy="640080"/>
+          </a:xfrm>
+          <a:prstGeom prst="roundRect">
+            <a:avLst/>
+          </a:prstGeom>
+          <a:solidFill>
+            <a:srgbClr val="C9F73A"/>
+          </a:solidFill>
+          <a:ln>
+            <a:noFill/>
+          </a:ln>
+          <a:effectLst/>
+        </p:spPr>
+        <p:style>
+          <a:lnRef idx="1">
+            <a:schemeClr val="accent1"/>
+          </a:lnRef>
+          <a:fillRef idx="3">
+            <a:schemeClr val="accent1"/>
+          </a:fillRef>
+          <a:effectRef idx="2">
+            <a:schemeClr val="accent1"/>
+          </a:effectRef>
+          <a:fontRef idx="minor">
+            <a:schemeClr val="lt1"/>
+          </a:fontRef>
+        </p:style>
+        <p:txBody>
+          <a:bodyPr rtlCol="0" anchor="ctr"/>
+          <a:lstStyle/>
+          <a:p>
+            <a:pPr algn="ctr"/>
+          </a:p>
+        </p:txBody>
+      </p:sp>
+      <p:sp>
+        <p:nvSpPr>
+          <p:cNvPr id="12" name="TextBox 11"/>
+          <p:cNvSpPr txBox="1"/>
+          <p:nvPr/>
+        </p:nvSpPr>
+        <p:spPr>
+          <a:xfrm>
+            <a:off x="640080" y="5230368"/>
+            <a:ext cx="2194560" cy="457200"/>
+          </a:xfrm>
+          <a:prstGeom prst="rect">
+            <a:avLst/>
+          </a:prstGeom>
+          <a:noFill/>
+        </p:spPr>
+        <p:txBody>
+          <a:bodyPr wrap="square">
+            <a:spAutoFit/>
+          </a:bodyPr>
+          <a:lstStyle/>
+          <a:p>
+            <a:pPr algn="ctr"/>
+            <a:r>
+              <a:rPr sz="1500" b="1">
+                <a:solidFill>
+                  <a:srgbClr val="1A1A1A"/>
+                </a:solidFill>
+                <a:latin typeface="Inter"/>
+              </a:rPr>
+              <a:t>Primary</a:t>
+            </a:r>
+          </a:p>
+        </p:txBody>
+      </p:sp>
+      <p:sp>
+        <p:nvSpPr>
+          <p:cNvPr id="13" name="Rounded Rectangle 12"/>
+          <p:cNvSpPr/>
+          <p:nvPr/>
+        </p:nvSpPr>
+        <p:spPr>
+          <a:xfrm>
+            <a:off x="3017520" y="5120640"/>
+            <a:ext cx="2194560" cy="640080"/>
+          </a:xfrm>
+          <a:prstGeom prst="roundRect">
+            <a:avLst/>
+          </a:prstGeom>
+          <a:solidFill>
+            <a:srgbClr val="24D8CC"/>
+          </a:solidFill>
+          <a:ln>
+            <a:noFill/>
+          </a:ln>
+          <a:effectLst/>
+        </p:spPr>
+        <p:style>
+          <a:lnRef idx="1">
+            <a:schemeClr val="accent1"/>
+          </a:lnRef>
+          <a:fillRef idx="3">
+            <a:schemeClr val="accent1"/>
+          </a:fillRef>
+          <a:effectRef idx="2">
+            <a:schemeClr val="accent1"/>
+          </a:effectRef>
+          <a:fontRef idx="minor">
+            <a:schemeClr val="lt1"/>
+          </a:fontRef>
+        </p:style>
+        <p:txBody>
+          <a:bodyPr rtlCol="0" anchor="ctr"/>
+          <a:lstStyle/>
+          <a:p>
+            <a:pPr algn="ctr"/>
+          </a:p>
+        </p:txBody>
+      </p:sp>
+      <p:sp>
+        <p:nvSpPr>
+          <p:cNvPr id="14" name="TextBox 13"/>
+          <p:cNvSpPr txBox="1"/>
+          <p:nvPr/>
+        </p:nvSpPr>
+        <p:spPr>
+          <a:xfrm>
+            <a:off x="3017520" y="5230368"/>
+            <a:ext cx="2194560" cy="457200"/>
+          </a:xfrm>
+          <a:prstGeom prst="rect">
+            <a:avLst/>
+          </a:prstGeom>
+          <a:noFill/>
+        </p:spPr>
+        <p:txBody>
+          <a:bodyPr wrap="square">
+            <a:spAutoFit/>
+          </a:bodyPr>
+          <a:lstStyle/>
+          <a:p>
+            <a:pPr algn="ctr"/>
+            <a:r>
+              <a:rPr sz="1500" b="1">
+                <a:solidFill>
+                  <a:srgbClr val="1A1A1A"/>
+                </a:solidFill>
+                <a:latin typeface="Inter"/>
+              </a:rPr>
+              <a:t>Accent</a:t>
             </a:r>
           </a:p>
         </p:txBody>

</xml_diff>